<commit_message>
Add overall morning/evening diff (not per-AP)
Two new aggregated diff visualizations covering all top-8 APs:

  overall_diff_mean.png   每格取 8 個 AP 的 RSSI 平均後做 evening - morning,
                          色帶 ±3 dBm,avg +0.52 dBm。最直觀的「整體訊號是否
                          普遍變強/變弱」視角。本實驗大部分區域偏紅 → 人少時
                          2.4 GHz 受人體吸收減少 → 平均 RSSI 上升。

  overall_diff_best.png   每格取「8 個 AP 中最強」做差;色帶 ±6 dBm,
                          avg +0.32 dBm。紅藍混合是因為 best AP 早晚可能換,
                          差值放大。

兩張各有用途:mean 看「整體訊號 climate」變化;best 看「最強訊號的穩定度」。

PPTX +2 張(22b/c),總 29 slides。
</commit_message>
<xml_diff>
--- a/CV2X_Lab2_presentation.pptx
+++ b/CV2X_Lab2_presentation.pptx
@@ -32,6 +32,8 @@
     <p:sldId id="280" r:id="rId31"/>
     <p:sldId id="281" r:id="rId32"/>
     <p:sldId id="282" r:id="rId33"/>
+    <p:sldId id="283" r:id="rId34"/>
+    <p:sldId id="284" r:id="rId35"/>
   </p:sldIdLst>
   <p:sldSz cx="12191695" cy="6858000" type="screen4x3"/>
   <p:notesSz cx="6858000" cy="9144000"/>
@@ -6329,7 +6331,7 @@
                   <a:srgbClr val="1F4E79"/>
                 </a:solidFill>
               </a:rPr>
-              <a:t>早晚 RSSI 差異熱圖(BMELab)</a:t>
+              <a:t>早晚 RSSI 差異熱圖(BMELab,per-AP)</a:t>
             </a:r>
           </a:p>
         </p:txBody>
@@ -6380,7 +6382,7 @@
             <a:pPr/>
             <a:r>
               <a:rPr sz="1500"/>
-              <a:t>色帶 ±15 dBm,本實驗最大 ±2.6 dBm 已是明顯統計顯著</a:t>
+              <a:t>色帶 ±15 dBm</a:t>
             </a:r>
           </a:p>
         </p:txBody>
@@ -6438,7 +6440,7 @@
                   <a:srgbClr val="555555"/>
                 </a:solidFill>
               </a:rPr>
-              <a:t>Δ = evening − morning;紅 = 晚上更強,藍 = 晚上更弱;BMELab 整體 +2.6 dBm</a:t>
+              <a:t>Δ = evening − morning;紅 = 晚上更強,藍 = 晚上更弱;BMELab 整體 +1.8 dBm</a:t>
             </a:r>
           </a:p>
         </p:txBody>
@@ -6489,7 +6491,7 @@
                   <a:srgbClr val="1F4E79"/>
                 </a:solidFill>
               </a:rPr>
-              <a:t>早晚對比觀察(物理解讀)</a:t>
+              <a:t>整體早晚對比(8 個 AP 平均 RSSI)</a:t>
             </a:r>
           </a:p>
         </p:txBody>
@@ -6502,8 +6504,8 @@
         </p:nvSpPr>
         <p:spPr>
           <a:xfrm>
-            <a:off x="640080" y="1188720"/>
-            <a:ext cx="10972800" cy="5029200"/>
+            <a:off x="457200" y="914400"/>
+            <a:ext cx="4389120" cy="5029200"/>
           </a:xfrm>
           <a:prstGeom prst="rect">
             <a:avLst/>
@@ -6518,57 +6520,87 @@
           <a:p>
             <a:pPr/>
             <a:r>
-              <a:rPr sz="2000"/>
-              <a:t>實驗室 AP(BMELab, ASUS_A8, HP printers):晚上一致 +2.0 ~ +2.6 dBm</a:t>
-            </a:r>
-          </a:p>
-          <a:p>
-            <a:pPr/>
-            <a:r>
-              <a:rPr sz="2000"/>
-              <a:t>   → 晚上實驗室人少,2.4 GHz 受人體水分子吸收 / 多徑散射減少</a:t>
-            </a:r>
-          </a:p>
-          <a:p>
-            <a:pPr/>
-            <a:r>
-              <a:rPr sz="2000"/>
-              <a:t>校園公共 AP(NYCU, NYCU-Seminar, NYCU-Alumni, Wiwynn_Lab):晚上 -1.4 ~ -2.0 dBm</a:t>
-            </a:r>
-          </a:p>
-          <a:p>
-            <a:pPr/>
-            <a:r>
-              <a:rPr sz="2000"/>
-              <a:t>   → 學校設備 load-balancing 晚上降功率;或 802.11k 主動調功率</a:t>
-            </a:r>
-          </a:p>
-          <a:p>
-            <a:pPr/>
-            <a:r>
-              <a:rPr sz="2000"/>
-              <a:t>校外住宅 AP(arai_*, ARA_*):晚上 +1.6 ~ +1.8 dBm</a:t>
-            </a:r>
-          </a:p>
-          <a:p>
-            <a:pPr/>
-            <a:r>
-              <a:rPr sz="2000"/>
-              <a:t>   → 室內活動減少,跨建築物的多徑衰減減少</a:t>
-            </a:r>
-          </a:p>
-          <a:p>
-            <a:pPr/>
-            <a:r>
-              <a:rPr sz="2000"/>
-              <a:t>整體 RSSI 變動 &lt; ±2.6 dBm,跟 indoor wifi short-term variance(±3~5 dBm)相當</a:t>
-            </a:r>
-          </a:p>
-          <a:p>
-            <a:pPr/>
-            <a:r>
-              <a:rPr sz="2000"/>
-              <a:t>結論:此 fingerprint dataset 跨時段可重用,但 lab AP 在「人數差很多」時需要校正</a:t>
+              <a:rPr sz="1500"/>
+              <a:t>大部分區域偏紅 = 平均訊號晚上比早上強</a:t>
+            </a:r>
+          </a:p>
+          <a:p>
+            <a:pPr/>
+            <a:r>
+              <a:rPr sz="1500"/>
+              <a:t>人少 → 人體吸收減少 → 訊號普遍提升</a:t>
+            </a:r>
+          </a:p>
+          <a:p>
+            <a:pPr/>
+            <a:r>
+              <a:rPr sz="1500"/>
+              <a:t>少數藍色區 = 局部位置反而變弱(可能是行人剛好在那段時間)</a:t>
+            </a:r>
+          </a:p>
+          <a:p>
+            <a:pPr/>
+            <a:r>
+              <a:rPr sz="1500"/>
+              <a:t>色帶 ±3 dBm(比 per-AP 收緊,因為 mean 變化幅度小)</a:t>
+            </a:r>
+          </a:p>
+        </p:txBody>
+      </p:sp>
+      <p:pic>
+        <p:nvPicPr>
+          <p:cNvPr id="4" name="Picture 3" descr="overall_diff_mean.png"/>
+          <p:cNvPicPr>
+            <a:picLocks noChangeAspect="1"/>
+          </p:cNvPicPr>
+          <p:nvPr/>
+        </p:nvPicPr>
+        <p:blipFill>
+          <a:blip r:embed="rId2"/>
+          <a:stretch>
+            <a:fillRect/>
+          </a:stretch>
+        </p:blipFill>
+        <p:spPr>
+          <a:xfrm>
+            <a:off x="6175004" y="914400"/>
+            <a:ext cx="4657830" cy="5212080"/>
+          </a:xfrm>
+          <a:prstGeom prst="rect">
+            <a:avLst/>
+          </a:prstGeom>
+        </p:spPr>
+      </p:pic>
+      <p:sp>
+        <p:nvSpPr>
+          <p:cNvPr id="5" name="TextBox 4"/>
+          <p:cNvSpPr txBox="1"/>
+          <p:nvPr/>
+        </p:nvSpPr>
+        <p:spPr>
+          <a:xfrm>
+            <a:off x="457200" y="6080760"/>
+            <a:ext cx="11338560" cy="457200"/>
+          </a:xfrm>
+          <a:prstGeom prst="rect">
+            <a:avLst/>
+          </a:prstGeom>
+          <a:noFill/>
+        </p:spPr>
+        <p:txBody>
+          <a:bodyPr wrap="none">
+            <a:spAutoFit/>
+          </a:bodyPr>
+          <a:lstStyle/>
+          <a:p>
+            <a:pPr algn="ctr"/>
+            <a:r>
+              <a:rPr sz="1400" i="1">
+                <a:solidFill>
+                  <a:srgbClr val="555555"/>
+                </a:solidFill>
+              </a:rPr>
+              <a:t>每格取 8 個 top AP 的 RSSI 平均,evening − morning;avg +0.52 dBm</a:t>
             </a:r>
           </a:p>
         </p:txBody>
@@ -6619,7 +6651,7 @@
                   <a:srgbClr val="1F4E79"/>
                 </a:solidFill>
               </a:rPr>
-              <a:t>ROS node 分工(對應評分項)</a:t>
+              <a:t>整體早晚對比(8 個 AP 最強訊號)</a:t>
             </a:r>
           </a:p>
         </p:txBody>
@@ -6632,8 +6664,8 @@
         </p:nvSpPr>
         <p:spPr>
           <a:xfrm>
-            <a:off x="640080" y="1188720"/>
-            <a:ext cx="10972800" cy="5029200"/>
+            <a:off x="457200" y="914400"/>
+            <a:ext cx="4389120" cy="5029200"/>
           </a:xfrm>
           <a:prstGeom prst="rect">
             <a:avLst/>
@@ -6648,57 +6680,87 @@
           <a:p>
             <a:pPr/>
             <a:r>
-              <a:rPr sz="2000"/>
-              <a:t>hlds_laser_publisher (Pi) → 地圖完整度 / 軌跡:/scan</a:t>
-            </a:r>
-          </a:p>
-          <a:p>
-            <a:pPr/>
-            <a:r>
-              <a:rPr sz="2000"/>
-              <a:t>turtlebot3_node + diff_drive_controller (Pi) → 軌跡:/odom + /tf odom→base</a:t>
-            </a:r>
-          </a:p>
-          <a:p>
-            <a:pPr/>
-            <a:r>
-              <a:rPr sz="2000"/>
-              <a:t>esp32_bridge_node (Pi) → 如何記錄 WiFi:/wifi_scan,event-driven</a:t>
-            </a:r>
-          </a:p>
-          <a:p>
-            <a:pPr/>
-            <a:r>
-              <a:rPr sz="2000"/>
-              <a:t>data_collector_node (Pi) → wifi+pose 配對:配 scan stamp 的 TF,寫 jsonl</a:t>
-            </a:r>
-          </a:p>
-          <a:p>
-            <a:pPr/>
-            <a:r>
-              <a:rPr sz="2000"/>
-              <a:t>pose_tracker_node (Pi) → trajectory:TF → /robot_pose</a:t>
-            </a:r>
-          </a:p>
-          <a:p>
-            <a:pPr/>
-            <a:r>
-              <a:rPr sz="2000"/>
-              <a:t>amcl + map_server (VM) → 絕對座標:particle filter → /tf map→odom</a:t>
-            </a:r>
-          </a:p>
-          <a:p>
-            <a:pPr/>
-            <a:r>
-              <a:rPr sz="2000"/>
-              <a:t>previous_paths_publisher (VM) → 駕駛輔助:讀 CSV 發 MarkerArray 給 RViz</a:t>
-            </a:r>
-          </a:p>
-          <a:p>
-            <a:pPr/>
-            <a:r>
-              <a:rPr sz="2000"/>
-              <a:t>rviz2 (VM) → 視覺化:map + tf + scan + trajectory + previous_paths</a:t>
+              <a:rPr sz="1500"/>
+              <a:t>紅藍混合 = best 訊號早晚相對穩定</a:t>
+            </a:r>
+          </a:p>
+          <a:p>
+            <a:pPr/>
+            <a:r>
+              <a:rPr sz="1500"/>
+              <a:t>原因:每格的「最強 AP」早晚可能不同</a:t>
+            </a:r>
+          </a:p>
+          <a:p>
+            <a:pPr/>
+            <a:r>
+              <a:rPr sz="1500"/>
+              <a:t>某些區域 best AP 變了 → 差值波動較大</a:t>
+            </a:r>
+          </a:p>
+          <a:p>
+            <a:pPr/>
+            <a:r>
+              <a:rPr sz="1500"/>
+              <a:t>色帶 ±6 dBm</a:t>
+            </a:r>
+          </a:p>
+        </p:txBody>
+      </p:sp>
+      <p:pic>
+        <p:nvPicPr>
+          <p:cNvPr id="4" name="Picture 3" descr="overall_diff_best.png"/>
+          <p:cNvPicPr>
+            <a:picLocks noChangeAspect="1"/>
+          </p:cNvPicPr>
+          <p:nvPr/>
+        </p:nvPicPr>
+        <p:blipFill>
+          <a:blip r:embed="rId2"/>
+          <a:stretch>
+            <a:fillRect/>
+          </a:stretch>
+        </p:blipFill>
+        <p:spPr>
+          <a:xfrm>
+            <a:off x="6175004" y="914400"/>
+            <a:ext cx="4657830" cy="5212080"/>
+          </a:xfrm>
+          <a:prstGeom prst="rect">
+            <a:avLst/>
+          </a:prstGeom>
+        </p:spPr>
+      </p:pic>
+      <p:sp>
+        <p:nvSpPr>
+          <p:cNvPr id="5" name="TextBox 4"/>
+          <p:cNvSpPr txBox="1"/>
+          <p:nvPr/>
+        </p:nvSpPr>
+        <p:spPr>
+          <a:xfrm>
+            <a:off x="457200" y="6080760"/>
+            <a:ext cx="11338560" cy="457200"/>
+          </a:xfrm>
+          <a:prstGeom prst="rect">
+            <a:avLst/>
+          </a:prstGeom>
+          <a:noFill/>
+        </p:spPr>
+        <p:txBody>
+          <a:bodyPr wrap="none">
+            <a:spAutoFit/>
+          </a:bodyPr>
+          <a:lstStyle/>
+          <a:p>
+            <a:pPr algn="ctr"/>
+            <a:r>
+              <a:rPr sz="1400" i="1">
+                <a:solidFill>
+                  <a:srgbClr val="555555"/>
+                </a:solidFill>
+              </a:rPr>
+              <a:t>每格取 8 個 AP 最強的那台,evening − morning;avg +0.32 dBm</a:t>
             </a:r>
           </a:p>
         </p:txBody>
@@ -6749,6 +6811,266 @@
                   <a:srgbClr val="1F4E79"/>
                 </a:solidFill>
               </a:rPr>
+              <a:t>早晚對比觀察(物理解讀)</a:t>
+            </a:r>
+          </a:p>
+        </p:txBody>
+      </p:sp>
+      <p:sp>
+        <p:nvSpPr>
+          <p:cNvPr id="3" name="TextBox 2"/>
+          <p:cNvSpPr txBox="1"/>
+          <p:nvPr/>
+        </p:nvSpPr>
+        <p:spPr>
+          <a:xfrm>
+            <a:off x="640080" y="1188720"/>
+            <a:ext cx="10972800" cy="5029200"/>
+          </a:xfrm>
+          <a:prstGeom prst="rect">
+            <a:avLst/>
+          </a:prstGeom>
+          <a:noFill/>
+        </p:spPr>
+        <p:txBody>
+          <a:bodyPr wrap="square">
+            <a:spAutoFit/>
+          </a:bodyPr>
+          <a:lstStyle/>
+          <a:p>
+            <a:pPr/>
+            <a:r>
+              <a:rPr sz="2000"/>
+              <a:t>實驗室 AP(BMELab, ASUS_A8, HP printers):晚上一致 +2.0 ~ +2.6 dBm</a:t>
+            </a:r>
+          </a:p>
+          <a:p>
+            <a:pPr/>
+            <a:r>
+              <a:rPr sz="2000"/>
+              <a:t>   → 晚上實驗室人少,2.4 GHz 受人體水分子吸收 / 多徑散射減少</a:t>
+            </a:r>
+          </a:p>
+          <a:p>
+            <a:pPr/>
+            <a:r>
+              <a:rPr sz="2000"/>
+              <a:t>校園公共 AP(NYCU, NYCU-Seminar, NYCU-Alumni, Wiwynn_Lab):晚上 -1.4 ~ -2.0 dBm</a:t>
+            </a:r>
+          </a:p>
+          <a:p>
+            <a:pPr/>
+            <a:r>
+              <a:rPr sz="2000"/>
+              <a:t>   → 學校設備 load-balancing 晚上降功率;或 802.11k 主動調功率</a:t>
+            </a:r>
+          </a:p>
+          <a:p>
+            <a:pPr/>
+            <a:r>
+              <a:rPr sz="2000"/>
+              <a:t>校外住宅 AP(arai_*, ARA_*):晚上 +1.6 ~ +1.8 dBm</a:t>
+            </a:r>
+          </a:p>
+          <a:p>
+            <a:pPr/>
+            <a:r>
+              <a:rPr sz="2000"/>
+              <a:t>   → 室內活動減少,跨建築物的多徑衰減減少</a:t>
+            </a:r>
+          </a:p>
+          <a:p>
+            <a:pPr/>
+            <a:r>
+              <a:rPr sz="2000"/>
+              <a:t>整體 RSSI 變動 &lt; ±2.6 dBm,跟 indoor wifi short-term variance(±3~5 dBm)相當</a:t>
+            </a:r>
+          </a:p>
+          <a:p>
+            <a:pPr/>
+            <a:r>
+              <a:rPr sz="2000"/>
+              <a:t>結論:此 fingerprint dataset 跨時段可重用,但 lab AP 在「人數差很多」時需要校正</a:t>
+            </a:r>
+          </a:p>
+        </p:txBody>
+      </p:sp>
+    </p:spTree>
+  </p:cSld>
+  <p:clrMapOvr>
+    <a:masterClrMapping/>
+  </p:clrMapOvr>
+</p:sld>
+</file>
+
+<file path=ppt/slides/slide26.xml><?xml version="1.0" encoding="utf-8"?>
+<p:sld xmlns:a="http://schemas.openxmlformats.org/drawingml/2006/main" xmlns:p="http://schemas.openxmlformats.org/presentationml/2006/main" xmlns:r="http://schemas.openxmlformats.org/officeDocument/2006/relationships">
+  <p:cSld>
+    <p:spTree>
+      <p:nvGrpSpPr>
+        <p:cNvPr id="1" name=""/>
+        <p:cNvGrpSpPr/>
+        <p:nvPr/>
+      </p:nvGrpSpPr>
+      <p:grpSpPr/>
+      <p:sp>
+        <p:nvSpPr>
+          <p:cNvPr id="2" name="TextBox 1"/>
+          <p:cNvSpPr txBox="1"/>
+          <p:nvPr/>
+        </p:nvSpPr>
+        <p:spPr>
+          <a:xfrm>
+            <a:off x="457200" y="228600"/>
+            <a:ext cx="11338560" cy="640080"/>
+          </a:xfrm>
+          <a:prstGeom prst="rect">
+            <a:avLst/>
+          </a:prstGeom>
+          <a:noFill/>
+        </p:spPr>
+        <p:txBody>
+          <a:bodyPr wrap="none">
+            <a:spAutoFit/>
+          </a:bodyPr>
+          <a:lstStyle/>
+          <a:p>
+            <a:r>
+              <a:rPr sz="2800" b="1">
+                <a:solidFill>
+                  <a:srgbClr val="1F4E79"/>
+                </a:solidFill>
+              </a:rPr>
+              <a:t>ROS node 分工(對應評分項)</a:t>
+            </a:r>
+          </a:p>
+        </p:txBody>
+      </p:sp>
+      <p:sp>
+        <p:nvSpPr>
+          <p:cNvPr id="3" name="TextBox 2"/>
+          <p:cNvSpPr txBox="1"/>
+          <p:nvPr/>
+        </p:nvSpPr>
+        <p:spPr>
+          <a:xfrm>
+            <a:off x="640080" y="1188720"/>
+            <a:ext cx="10972800" cy="5029200"/>
+          </a:xfrm>
+          <a:prstGeom prst="rect">
+            <a:avLst/>
+          </a:prstGeom>
+          <a:noFill/>
+        </p:spPr>
+        <p:txBody>
+          <a:bodyPr wrap="square">
+            <a:spAutoFit/>
+          </a:bodyPr>
+          <a:lstStyle/>
+          <a:p>
+            <a:pPr/>
+            <a:r>
+              <a:rPr sz="2000"/>
+              <a:t>hlds_laser_publisher (Pi) → 地圖完整度 / 軌跡:/scan</a:t>
+            </a:r>
+          </a:p>
+          <a:p>
+            <a:pPr/>
+            <a:r>
+              <a:rPr sz="2000"/>
+              <a:t>turtlebot3_node + diff_drive_controller (Pi) → 軌跡:/odom + /tf odom→base</a:t>
+            </a:r>
+          </a:p>
+          <a:p>
+            <a:pPr/>
+            <a:r>
+              <a:rPr sz="2000"/>
+              <a:t>esp32_bridge_node (Pi) → 如何記錄 WiFi:/wifi_scan,event-driven</a:t>
+            </a:r>
+          </a:p>
+          <a:p>
+            <a:pPr/>
+            <a:r>
+              <a:rPr sz="2000"/>
+              <a:t>data_collector_node (Pi) → wifi+pose 配對:配 scan stamp 的 TF,寫 jsonl</a:t>
+            </a:r>
+          </a:p>
+          <a:p>
+            <a:pPr/>
+            <a:r>
+              <a:rPr sz="2000"/>
+              <a:t>pose_tracker_node (Pi) → trajectory:TF → /robot_pose</a:t>
+            </a:r>
+          </a:p>
+          <a:p>
+            <a:pPr/>
+            <a:r>
+              <a:rPr sz="2000"/>
+              <a:t>amcl + map_server (VM) → 絕對座標:particle filter → /tf map→odom</a:t>
+            </a:r>
+          </a:p>
+          <a:p>
+            <a:pPr/>
+            <a:r>
+              <a:rPr sz="2000"/>
+              <a:t>previous_paths_publisher (VM) → 駕駛輔助:讀 CSV 發 MarkerArray 給 RViz</a:t>
+            </a:r>
+          </a:p>
+          <a:p>
+            <a:pPr/>
+            <a:r>
+              <a:rPr sz="2000"/>
+              <a:t>rviz2 (VM) → 視覺化:map + tf + scan + trajectory + previous_paths</a:t>
+            </a:r>
+          </a:p>
+        </p:txBody>
+      </p:sp>
+    </p:spTree>
+  </p:cSld>
+  <p:clrMapOvr>
+    <a:masterClrMapping/>
+  </p:clrMapOvr>
+</p:sld>
+</file>
+
+<file path=ppt/slides/slide27.xml><?xml version="1.0" encoding="utf-8"?>
+<p:sld xmlns:a="http://schemas.openxmlformats.org/drawingml/2006/main" xmlns:p="http://schemas.openxmlformats.org/presentationml/2006/main" xmlns:r="http://schemas.openxmlformats.org/officeDocument/2006/relationships">
+  <p:cSld>
+    <p:spTree>
+      <p:nvGrpSpPr>
+        <p:cNvPr id="1" name=""/>
+        <p:cNvGrpSpPr/>
+        <p:nvPr/>
+      </p:nvGrpSpPr>
+      <p:grpSpPr/>
+      <p:sp>
+        <p:nvSpPr>
+          <p:cNvPr id="2" name="TextBox 1"/>
+          <p:cNvSpPr txBox="1"/>
+          <p:nvPr/>
+        </p:nvSpPr>
+        <p:spPr>
+          <a:xfrm>
+            <a:off x="457200" y="228600"/>
+            <a:ext cx="11338560" cy="640080"/>
+          </a:xfrm>
+          <a:prstGeom prst="rect">
+            <a:avLst/>
+          </a:prstGeom>
+          <a:noFill/>
+        </p:spPr>
+        <p:txBody>
+          <a:bodyPr wrap="none">
+            <a:spAutoFit/>
+          </a:bodyPr>
+          <a:lstStyle/>
+          <a:p>
+            <a:r>
+              <a:rPr sz="2800" b="1">
+                <a:solidFill>
+                  <a:srgbClr val="1F4E79"/>
+                </a:solidFill>
+              </a:rPr>
               <a:t>蒐集統計總表</a:t>
             </a:r>
           </a:p>
@@ -7254,7 +7576,7 @@
 </p:sld>
 </file>
 
-<file path=ppt/slides/slide26.xml><?xml version="1.0" encoding="utf-8"?>
+<file path=ppt/slides/slide28.xml><?xml version="1.0" encoding="utf-8"?>
 <p:sld xmlns:a="http://schemas.openxmlformats.org/drawingml/2006/main" xmlns:p="http://schemas.openxmlformats.org/presentationml/2006/main" xmlns:r="http://schemas.openxmlformats.org/officeDocument/2006/relationships">
   <p:cSld>
     <p:spTree>
@@ -7370,7 +7692,7 @@
 </p:sld>
 </file>
 
-<file path=ppt/slides/slide27.xml><?xml version="1.0" encoding="utf-8"?>
+<file path=ppt/slides/slide29.xml><?xml version="1.0" encoding="utf-8"?>
 <p:sld xmlns:a="http://schemas.openxmlformats.org/drawingml/2006/main" xmlns:p="http://schemas.openxmlformats.org/presentationml/2006/main" xmlns:r="http://schemas.openxmlformats.org/officeDocument/2006/relationships">
   <p:cSld>
     <p:spTree>

</xml_diff>